<commit_message>
Made some final changes to the PowerPoint presentation
</commit_message>
<xml_diff>
--- a/EscapeAI/Escape AI - PowerPoint Presentation.pptx
+++ b/EscapeAI/Escape AI - PowerPoint Presentation.pptx
@@ -8,12 +8,12 @@
     <p:sldId id="256" r:id="rId2"/>
     <p:sldId id="257" r:id="rId3"/>
     <p:sldId id="264" r:id="rId4"/>
-    <p:sldId id="258" r:id="rId5"/>
-    <p:sldId id="259" r:id="rId6"/>
-    <p:sldId id="260" r:id="rId7"/>
-    <p:sldId id="261" r:id="rId8"/>
-    <p:sldId id="262" r:id="rId9"/>
-    <p:sldId id="263" r:id="rId10"/>
+    <p:sldId id="259" r:id="rId5"/>
+    <p:sldId id="258" r:id="rId6"/>
+    <p:sldId id="261" r:id="rId7"/>
+    <p:sldId id="260" r:id="rId8"/>
+    <p:sldId id="263" r:id="rId9"/>
+    <p:sldId id="262" r:id="rId10"/>
   </p:sldIdLst>
   <p:sldSz cx="12192000" cy="6858000"/>
   <p:notesSz cx="6858000" cy="9144000"/>
@@ -257,7 +257,7 @@
           <a:p>
             <a:fld id="{C764DE79-268F-4C1A-8933-263129D2AF90}" type="datetimeFigureOut">
               <a:rPr lang="en-US" dirty="0"/>
-              <a:t>2/28/2026</a:t>
+              <a:t>3/1/2026</a:t>
             </a:fld>
             <a:endParaRPr lang="en-US" dirty="0"/>
           </a:p>
@@ -425,7 +425,7 @@
           <a:p>
             <a:fld id="{C764DE79-268F-4C1A-8933-263129D2AF90}" type="datetimeFigureOut">
               <a:rPr lang="en-US" dirty="0"/>
-              <a:t>2/28/2026</a:t>
+              <a:t>3/1/2026</a:t>
             </a:fld>
             <a:endParaRPr lang="en-US" dirty="0"/>
           </a:p>
@@ -603,7 +603,7 @@
           <a:p>
             <a:fld id="{C764DE79-268F-4C1A-8933-263129D2AF90}" type="datetimeFigureOut">
               <a:rPr lang="en-US" dirty="0"/>
-              <a:t>2/28/2026</a:t>
+              <a:t>3/1/2026</a:t>
             </a:fld>
             <a:endParaRPr lang="en-US" dirty="0"/>
           </a:p>
@@ -771,7 +771,7 @@
           <a:p>
             <a:fld id="{C764DE79-268F-4C1A-8933-263129D2AF90}" type="datetimeFigureOut">
               <a:rPr lang="en-US" dirty="0"/>
-              <a:t>2/28/2026</a:t>
+              <a:t>3/1/2026</a:t>
             </a:fld>
             <a:endParaRPr lang="en-US" dirty="0"/>
           </a:p>
@@ -1016,7 +1016,7 @@
           <a:p>
             <a:fld id="{C764DE79-268F-4C1A-8933-263129D2AF90}" type="datetimeFigureOut">
               <a:rPr lang="en-US" dirty="0"/>
-              <a:t>2/28/2026</a:t>
+              <a:t>3/1/2026</a:t>
             </a:fld>
             <a:endParaRPr lang="en-US" dirty="0"/>
           </a:p>
@@ -1245,7 +1245,7 @@
           <a:p>
             <a:fld id="{C764DE79-268F-4C1A-8933-263129D2AF90}" type="datetimeFigureOut">
               <a:rPr lang="en-US" dirty="0"/>
-              <a:t>2/28/2026</a:t>
+              <a:t>3/1/2026</a:t>
             </a:fld>
             <a:endParaRPr lang="en-US" dirty="0"/>
           </a:p>
@@ -1609,7 +1609,7 @@
           <a:p>
             <a:fld id="{C764DE79-268F-4C1A-8933-263129D2AF90}" type="datetimeFigureOut">
               <a:rPr lang="en-US" dirty="0"/>
-              <a:t>2/28/2026</a:t>
+              <a:t>3/1/2026</a:t>
             </a:fld>
             <a:endParaRPr lang="en-US" dirty="0"/>
           </a:p>
@@ -1726,7 +1726,7 @@
           <a:p>
             <a:fld id="{C764DE79-268F-4C1A-8933-263129D2AF90}" type="datetimeFigureOut">
               <a:rPr lang="en-US" dirty="0"/>
-              <a:t>2/28/2026</a:t>
+              <a:t>3/1/2026</a:t>
             </a:fld>
             <a:endParaRPr lang="en-US" dirty="0"/>
           </a:p>
@@ -1821,7 +1821,7 @@
           <a:p>
             <a:fld id="{C764DE79-268F-4C1A-8933-263129D2AF90}" type="datetimeFigureOut">
               <a:rPr lang="en-US" dirty="0"/>
-              <a:t>2/28/2026</a:t>
+              <a:t>3/1/2026</a:t>
             </a:fld>
             <a:endParaRPr lang="en-US" dirty="0"/>
           </a:p>
@@ -2096,7 +2096,7 @@
           <a:p>
             <a:fld id="{C764DE79-268F-4C1A-8933-263129D2AF90}" type="datetimeFigureOut">
               <a:rPr lang="en-US" dirty="0"/>
-              <a:t>2/28/2026</a:t>
+              <a:t>3/1/2026</a:t>
             </a:fld>
             <a:endParaRPr lang="en-US" dirty="0"/>
           </a:p>
@@ -2348,7 +2348,7 @@
           <a:p>
             <a:fld id="{C764DE79-268F-4C1A-8933-263129D2AF90}" type="datetimeFigureOut">
               <a:rPr lang="en-US" dirty="0"/>
-              <a:t>2/28/2026</a:t>
+              <a:t>3/1/2026</a:t>
             </a:fld>
             <a:endParaRPr lang="en-US" dirty="0"/>
           </a:p>
@@ -2559,7 +2559,7 @@
           <a:p>
             <a:fld id="{C764DE79-268F-4C1A-8933-263129D2AF90}" type="datetimeFigureOut">
               <a:rPr lang="en-US" dirty="0"/>
-              <a:t>2/28/2026</a:t>
+              <a:t>3/1/2026</a:t>
             </a:fld>
             <a:endParaRPr lang="en-US" dirty="0"/>
           </a:p>
@@ -3394,7 +3394,7 @@
           <p:cNvPr id="2" name="Title 1">
             <a:extLst>
               <a:ext uri="{FF2B5EF4-FFF2-40B4-BE49-F238E27FC236}">
-                <a16:creationId xmlns:a16="http://schemas.microsoft.com/office/drawing/2014/main" id="{B65BB491-F295-C6E8-0537-373393E9E1F1}"/>
+                <a16:creationId xmlns:a16="http://schemas.microsoft.com/office/drawing/2014/main" id="{9C6C9674-1EDF-79ED-3F2E-3D4FDBC23B59}"/>
               </a:ext>
             </a:extLst>
           </p:cNvPr>
@@ -3424,42 +3424,134 @@
           </a:p>
         </p:txBody>
       </p:sp>
-      <p:pic>
-        <p:nvPicPr>
-          <p:cNvPr id="8" name="Content Placeholder 7" descr="A screen shot of a computer&#10;&#10;AI-generated content may be incorrect.">
+      <p:sp>
+        <p:nvSpPr>
+          <p:cNvPr id="3" name="Content Placeholder 2">
             <a:extLst>
               <a:ext uri="{FF2B5EF4-FFF2-40B4-BE49-F238E27FC236}">
-                <a16:creationId xmlns:a16="http://schemas.microsoft.com/office/drawing/2014/main" id="{C8E2BF81-B171-BAAA-0E44-E838B78259ED}"/>
+                <a16:creationId xmlns:a16="http://schemas.microsoft.com/office/drawing/2014/main" id="{D2686ED4-D501-F2D7-03DF-8201C98C0220}"/>
               </a:ext>
             </a:extLst>
           </p:cNvPr>
-          <p:cNvPicPr>
-            <a:picLocks noGrp="1" noChangeAspect="1"/>
-          </p:cNvPicPr>
+          <p:cNvSpPr>
+            <a:spLocks noGrp="1"/>
+          </p:cNvSpPr>
           <p:nvPr>
             <p:ph idx="1"/>
           </p:nvPr>
-        </p:nvPicPr>
-        <p:blipFill>
-          <a:blip r:embed="rId2"/>
-          <a:stretch>
-            <a:fillRect/>
-          </a:stretch>
-        </p:blipFill>
-        <p:spPr>
-          <a:xfrm>
-            <a:off x="1488282" y="1681260"/>
-            <a:ext cx="9215437" cy="4473382"/>
-          </a:xfrm>
-          <a:prstGeom prst="rect">
-            <a:avLst/>
-          </a:prstGeom>
-        </p:spPr>
-      </p:pic>
+        </p:nvSpPr>
+        <p:spPr/>
+        <p:txBody>
+          <a:bodyPr vert="horz" lIns="91440" tIns="45720" rIns="91440" bIns="45720" rtlCol="0" anchor="t">
+            <a:normAutofit/>
+          </a:bodyPr>
+          <a:lstStyle/>
+          <a:p>
+            <a:r>
+              <a:rPr lang="en-GB" dirty="0">
+                <a:solidFill>
+                  <a:schemeClr val="bg1"/>
+                </a:solidFill>
+                <a:latin typeface="ADLaM Display"/>
+                <a:ea typeface="ADLaM Display"/>
+                <a:cs typeface="ADLaM Display"/>
+              </a:rPr>
+              <a:t>The player must solve the first puzzle by using a simple drag-and-drop interface to design and print a new wheel and wheel </a:t>
+            </a:r>
+            <a:r>
+              <a:rPr lang="en-GB">
+                <a:solidFill>
+                  <a:schemeClr val="bg1"/>
+                </a:solidFill>
+                <a:latin typeface="ADLaM Display"/>
+                <a:ea typeface="ADLaM Display"/>
+                <a:cs typeface="ADLaM Display"/>
+              </a:rPr>
+              <a:t>assembly for the broken robot.</a:t>
+            </a:r>
+            <a:endParaRPr lang="en-GB" dirty="0">
+              <a:solidFill>
+                <a:schemeClr val="bg1"/>
+              </a:solidFill>
+              <a:latin typeface="ADLaM Display"/>
+              <a:ea typeface="ADLaM Display"/>
+              <a:cs typeface="ADLaM Display"/>
+            </a:endParaRPr>
+          </a:p>
+          <a:p>
+            <a:r>
+              <a:rPr lang="en-GB">
+                <a:solidFill>
+                  <a:schemeClr val="bg1"/>
+                </a:solidFill>
+                <a:latin typeface="ADLaM Display"/>
+                <a:ea typeface="ADLaM Display"/>
+                <a:cs typeface="ADLaM Display"/>
+              </a:rPr>
+              <a:t>The theme of this exercise is </a:t>
+            </a:r>
+            <a:r>
+              <a:rPr lang="en-GB" b="1" i="1" u="sng">
+                <a:solidFill>
+                  <a:schemeClr val="bg1"/>
+                </a:solidFill>
+                <a:latin typeface="ADLaM Display"/>
+                <a:ea typeface="ADLaM Display"/>
+                <a:cs typeface="ADLaM Display"/>
+              </a:rPr>
+              <a:t>Computer-Aided Design (CAD)</a:t>
+            </a:r>
+            <a:r>
+              <a:rPr lang="en-GB" dirty="0">
+                <a:solidFill>
+                  <a:schemeClr val="bg1"/>
+                </a:solidFill>
+                <a:latin typeface="ADLaM Display"/>
+                <a:ea typeface="ADLaM Display"/>
+                <a:cs typeface="ADLaM Display"/>
+              </a:rPr>
+              <a:t> </a:t>
+            </a:r>
+            <a:r>
+              <a:rPr lang="en-GB">
+                <a:solidFill>
+                  <a:schemeClr val="bg1"/>
+                </a:solidFill>
+                <a:latin typeface="ADLaM Display"/>
+                <a:ea typeface="ADLaM Display"/>
+                <a:cs typeface="ADLaM Display"/>
+              </a:rPr>
+              <a:t>and the technology of </a:t>
+            </a:r>
+            <a:r>
+              <a:rPr lang="en-GB" b="1" i="1" u="sng">
+                <a:solidFill>
+                  <a:schemeClr val="bg1"/>
+                </a:solidFill>
+                <a:latin typeface="ADLaM Display"/>
+                <a:ea typeface="ADLaM Display"/>
+                <a:cs typeface="ADLaM Display"/>
+              </a:rPr>
+              <a:t>3D Printing</a:t>
+            </a:r>
+            <a:r>
+              <a:rPr lang="en-GB">
+                <a:solidFill>
+                  <a:schemeClr val="bg1"/>
+                </a:solidFill>
+                <a:latin typeface="ADLaM Display"/>
+                <a:ea typeface="ADLaM Display"/>
+                <a:cs typeface="ADLaM Display"/>
+              </a:rPr>
+              <a:t>.</a:t>
+            </a:r>
+          </a:p>
+        </p:txBody>
+      </p:sp>
     </p:spTree>
     <p:extLst>
       <p:ext uri="{BB962C8B-B14F-4D97-AF65-F5344CB8AC3E}">
-        <p14:creationId xmlns:p14="http://schemas.microsoft.com/office/powerpoint/2010/main" val="711651591"/>
+        <p14:creationId xmlns:p14="http://schemas.microsoft.com/office/powerpoint/2010/main" val="1227868791"/>
       </p:ext>
     </p:extLst>
   </p:cSld>
@@ -3499,7 +3591,7 @@
           <p:cNvPr id="2" name="Title 1">
             <a:extLst>
               <a:ext uri="{FF2B5EF4-FFF2-40B4-BE49-F238E27FC236}">
-                <a16:creationId xmlns:a16="http://schemas.microsoft.com/office/drawing/2014/main" id="{9C6C9674-1EDF-79ED-3F2E-3D4FDBC23B59}"/>
+                <a16:creationId xmlns:a16="http://schemas.microsoft.com/office/drawing/2014/main" id="{B65BB491-F295-C6E8-0537-373393E9E1F1}"/>
               </a:ext>
             </a:extLst>
           </p:cNvPr>
@@ -3529,134 +3621,48 @@
           </a:p>
         </p:txBody>
       </p:sp>
-      <p:sp>
-        <p:nvSpPr>
-          <p:cNvPr id="3" name="Content Placeholder 2">
+      <p:pic>
+        <p:nvPicPr>
+          <p:cNvPr id="6" name="Content Placeholder 5">
             <a:extLst>
               <a:ext uri="{FF2B5EF4-FFF2-40B4-BE49-F238E27FC236}">
-                <a16:creationId xmlns:a16="http://schemas.microsoft.com/office/drawing/2014/main" id="{D2686ED4-D501-F2D7-03DF-8201C98C0220}"/>
+                <a16:creationId xmlns:a16="http://schemas.microsoft.com/office/drawing/2014/main" id="{A2A8F1BA-166E-14C3-F007-BA11816798BA}"/>
               </a:ext>
             </a:extLst>
           </p:cNvPr>
-          <p:cNvSpPr>
-            <a:spLocks noGrp="1"/>
-          </p:cNvSpPr>
+          <p:cNvPicPr>
+            <a:picLocks noGrp="1" noChangeAspect="1"/>
+          </p:cNvPicPr>
           <p:nvPr>
             <p:ph idx="1"/>
           </p:nvPr>
-        </p:nvSpPr>
-        <p:spPr/>
-        <p:txBody>
-          <a:bodyPr vert="horz" lIns="91440" tIns="45720" rIns="91440" bIns="45720" rtlCol="0" anchor="t">
-            <a:normAutofit/>
-          </a:bodyPr>
-          <a:lstStyle/>
-          <a:p>
-            <a:r>
-              <a:rPr lang="en-GB" dirty="0">
-                <a:solidFill>
-                  <a:schemeClr val="bg1"/>
-                </a:solidFill>
-                <a:latin typeface="ADLaM Display"/>
-                <a:ea typeface="ADLaM Display"/>
-                <a:cs typeface="ADLaM Display"/>
-              </a:rPr>
-              <a:t>The player must solve the first puzzle by using a simple drag-and-drop interface to design and print a new wheel and wheel </a:t>
-            </a:r>
-            <a:r>
-              <a:rPr lang="en-GB">
-                <a:solidFill>
-                  <a:schemeClr val="bg1"/>
-                </a:solidFill>
-                <a:latin typeface="ADLaM Display"/>
-                <a:ea typeface="ADLaM Display"/>
-                <a:cs typeface="ADLaM Display"/>
-              </a:rPr>
-              <a:t>assembly for the broken robot.</a:t>
-            </a:r>
-            <a:endParaRPr lang="en-GB" dirty="0">
-              <a:solidFill>
-                <a:schemeClr val="bg1"/>
-              </a:solidFill>
-              <a:latin typeface="ADLaM Display"/>
-              <a:ea typeface="ADLaM Display"/>
-              <a:cs typeface="ADLaM Display"/>
-            </a:endParaRPr>
-          </a:p>
-          <a:p>
-            <a:r>
-              <a:rPr lang="en-GB">
-                <a:solidFill>
-                  <a:schemeClr val="bg1"/>
-                </a:solidFill>
-                <a:latin typeface="ADLaM Display"/>
-                <a:ea typeface="ADLaM Display"/>
-                <a:cs typeface="ADLaM Display"/>
-              </a:rPr>
-              <a:t>The theme of this exercise is </a:t>
-            </a:r>
-            <a:r>
-              <a:rPr lang="en-GB" b="1" i="1" u="sng">
-                <a:solidFill>
-                  <a:schemeClr val="bg1"/>
-                </a:solidFill>
-                <a:latin typeface="ADLaM Display"/>
-                <a:ea typeface="ADLaM Display"/>
-                <a:cs typeface="ADLaM Display"/>
-              </a:rPr>
-              <a:t>Computer-Aided Design (CAD)</a:t>
-            </a:r>
-            <a:r>
-              <a:rPr lang="en-GB" dirty="0">
-                <a:solidFill>
-                  <a:schemeClr val="bg1"/>
-                </a:solidFill>
-                <a:latin typeface="ADLaM Display"/>
-                <a:ea typeface="ADLaM Display"/>
-                <a:cs typeface="ADLaM Display"/>
-              </a:rPr>
-              <a:t> </a:t>
-            </a:r>
-            <a:r>
-              <a:rPr lang="en-GB">
-                <a:solidFill>
-                  <a:schemeClr val="bg1"/>
-                </a:solidFill>
-                <a:latin typeface="ADLaM Display"/>
-                <a:ea typeface="ADLaM Display"/>
-                <a:cs typeface="ADLaM Display"/>
-              </a:rPr>
-              <a:t>and the technology of </a:t>
-            </a:r>
-            <a:r>
-              <a:rPr lang="en-GB" b="1" i="1" u="sng">
-                <a:solidFill>
-                  <a:schemeClr val="bg1"/>
-                </a:solidFill>
-                <a:latin typeface="ADLaM Display"/>
-                <a:ea typeface="ADLaM Display"/>
-                <a:cs typeface="ADLaM Display"/>
-              </a:rPr>
-              <a:t>3D Printing</a:t>
-            </a:r>
-            <a:r>
-              <a:rPr lang="en-GB">
-                <a:solidFill>
-                  <a:schemeClr val="bg1"/>
-                </a:solidFill>
-                <a:latin typeface="ADLaM Display"/>
-                <a:ea typeface="ADLaM Display"/>
-                <a:cs typeface="ADLaM Display"/>
-              </a:rPr>
-              <a:t>.</a:t>
-            </a:r>
-          </a:p>
-        </p:txBody>
-      </p:sp>
+        </p:nvPicPr>
+        <p:blipFill>
+          <a:blip r:embed="rId2">
+            <a:extLst>
+              <a:ext uri="{28A0092B-C50C-407E-A947-70E740481C1C}">
+                <a14:useLocalDpi xmlns:a14="http://schemas.microsoft.com/office/drawing/2010/main" val="0"/>
+              </a:ext>
+            </a:extLst>
+          </a:blip>
+          <a:stretch>
+            <a:fillRect/>
+          </a:stretch>
+        </p:blipFill>
+        <p:spPr>
+          <a:xfrm>
+            <a:off x="1047234" y="1690688"/>
+            <a:ext cx="10097531" cy="4853772"/>
+          </a:xfrm>
+          <a:prstGeom prst="rect">
+            <a:avLst/>
+          </a:prstGeom>
+        </p:spPr>
+      </p:pic>
     </p:spTree>
     <p:extLst>
       <p:ext uri="{BB962C8B-B14F-4D97-AF65-F5344CB8AC3E}">
-        <p14:creationId xmlns:p14="http://schemas.microsoft.com/office/powerpoint/2010/main" val="1227868791"/>
+        <p14:creationId xmlns:p14="http://schemas.microsoft.com/office/powerpoint/2010/main" val="711651591"/>
       </p:ext>
     </p:extLst>
   </p:cSld>
@@ -3696,7 +3702,7 @@
           <p:cNvPr id="2" name="Title 1">
             <a:extLst>
               <a:ext uri="{FF2B5EF4-FFF2-40B4-BE49-F238E27FC236}">
-                <a16:creationId xmlns:a16="http://schemas.microsoft.com/office/drawing/2014/main" id="{1520FC93-D3B6-0E7F-0B79-3E876D81A790}"/>
+                <a16:creationId xmlns:a16="http://schemas.microsoft.com/office/drawing/2014/main" id="{FD3E600A-D7D0-806B-7486-E0D58915138C}"/>
               </a:ext>
             </a:extLst>
           </p:cNvPr>
@@ -3726,42 +3732,103 @@
           </a:p>
         </p:txBody>
       </p:sp>
-      <p:pic>
-        <p:nvPicPr>
-          <p:cNvPr id="4" name="Content Placeholder 3" descr="A screenshot of a computer&#10;&#10;AI-generated content may be incorrect.">
+      <p:sp>
+        <p:nvSpPr>
+          <p:cNvPr id="3" name="Content Placeholder 2">
             <a:extLst>
               <a:ext uri="{FF2B5EF4-FFF2-40B4-BE49-F238E27FC236}">
-                <a16:creationId xmlns:a16="http://schemas.microsoft.com/office/drawing/2014/main" id="{A48916B1-1842-A411-C3DF-84504D4E2366}"/>
+                <a16:creationId xmlns:a16="http://schemas.microsoft.com/office/drawing/2014/main" id="{136CF22E-3FBB-EF53-1CEF-E20C696A863B}"/>
               </a:ext>
             </a:extLst>
           </p:cNvPr>
-          <p:cNvPicPr>
-            <a:picLocks noGrp="1" noChangeAspect="1"/>
-          </p:cNvPicPr>
+          <p:cNvSpPr>
+            <a:spLocks noGrp="1"/>
+          </p:cNvSpPr>
           <p:nvPr>
             <p:ph idx="1"/>
           </p:nvPr>
-        </p:nvPicPr>
-        <p:blipFill>
-          <a:blip r:embed="rId2"/>
-          <a:stretch>
-            <a:fillRect/>
-          </a:stretch>
-        </p:blipFill>
-        <p:spPr>
-          <a:xfrm>
-            <a:off x="1416844" y="1690300"/>
-            <a:ext cx="9370219" cy="4507128"/>
-          </a:xfrm>
-          <a:prstGeom prst="rect">
-            <a:avLst/>
-          </a:prstGeom>
-        </p:spPr>
-      </p:pic>
+        </p:nvSpPr>
+        <p:spPr/>
+        <p:txBody>
+          <a:bodyPr vert="horz" lIns="91440" tIns="45720" rIns="91440" bIns="45720" rtlCol="0" anchor="t">
+            <a:normAutofit/>
+          </a:bodyPr>
+          <a:lstStyle/>
+          <a:p>
+            <a:r>
+              <a:rPr lang="en-GB" dirty="0">
+                <a:solidFill>
+                  <a:schemeClr val="bg1"/>
+                </a:solidFill>
+                <a:latin typeface="ADLaM Display"/>
+                <a:ea typeface="ADLaM Display"/>
+                <a:cs typeface="ADLaM Display"/>
+              </a:rPr>
+              <a:t>After physically repairing the robot with the 3D printer and the new component, the player must then re-establish the wireless network connection between the PC and the robot.</a:t>
+            </a:r>
+          </a:p>
+          <a:p>
+            <a:r>
+              <a:rPr lang="en-GB" dirty="0">
+                <a:solidFill>
+                  <a:schemeClr val="bg1"/>
+                </a:solidFill>
+                <a:latin typeface="ADLaM Display"/>
+                <a:ea typeface="ADLaM Display"/>
+                <a:cs typeface="ADLaM Display"/>
+              </a:rPr>
+              <a:t>Puzzle involves changing IP Address, Subnet Mask and Gateway to make sure the robot and the PC are on the same network, as well as a very basic wiring task.</a:t>
+            </a:r>
+          </a:p>
+          <a:p>
+            <a:r>
+              <a:rPr lang="en-GB">
+                <a:solidFill>
+                  <a:schemeClr val="bg1"/>
+                </a:solidFill>
+                <a:latin typeface="ADLaM Display"/>
+                <a:ea typeface="ADLaM Display"/>
+                <a:cs typeface="ADLaM Display"/>
+              </a:rPr>
+              <a:t>This puzzle highlights the theme of </a:t>
+            </a:r>
+            <a:r>
+              <a:rPr lang="en-GB" b="1" i="1" u="sng">
+                <a:solidFill>
+                  <a:schemeClr val="bg1"/>
+                </a:solidFill>
+                <a:latin typeface="ADLaM Display"/>
+                <a:ea typeface="ADLaM Display"/>
+                <a:cs typeface="ADLaM Display"/>
+              </a:rPr>
+              <a:t>networking</a:t>
+            </a:r>
+            <a:r>
+              <a:rPr lang="en-GB">
+                <a:solidFill>
+                  <a:schemeClr val="bg1"/>
+                </a:solidFill>
+                <a:latin typeface="ADLaM Display"/>
+                <a:ea typeface="ADLaM Display"/>
+                <a:cs typeface="ADLaM Display"/>
+              </a:rPr>
+              <a:t>.</a:t>
+            </a:r>
+            <a:endParaRPr lang="en-GB" dirty="0">
+              <a:solidFill>
+                <a:schemeClr val="bg1"/>
+              </a:solidFill>
+              <a:latin typeface="ADLaM Display"/>
+              <a:ea typeface="ADLaM Display"/>
+              <a:cs typeface="ADLaM Display"/>
+            </a:endParaRPr>
+          </a:p>
+        </p:txBody>
+      </p:sp>
     </p:spTree>
     <p:extLst>
       <p:ext uri="{BB962C8B-B14F-4D97-AF65-F5344CB8AC3E}">
-        <p14:creationId xmlns:p14="http://schemas.microsoft.com/office/powerpoint/2010/main" val="418780350"/>
+        <p14:creationId xmlns:p14="http://schemas.microsoft.com/office/powerpoint/2010/main" val="1832575804"/>
       </p:ext>
     </p:extLst>
   </p:cSld>
@@ -3801,7 +3868,7 @@
           <p:cNvPr id="2" name="Title 1">
             <a:extLst>
               <a:ext uri="{FF2B5EF4-FFF2-40B4-BE49-F238E27FC236}">
-                <a16:creationId xmlns:a16="http://schemas.microsoft.com/office/drawing/2014/main" id="{FD3E600A-D7D0-806B-7486-E0D58915138C}"/>
+                <a16:creationId xmlns:a16="http://schemas.microsoft.com/office/drawing/2014/main" id="{1520FC93-D3B6-0E7F-0B79-3E876D81A790}"/>
               </a:ext>
             </a:extLst>
           </p:cNvPr>
@@ -3831,103 +3898,48 @@
           </a:p>
         </p:txBody>
       </p:sp>
-      <p:sp>
-        <p:nvSpPr>
-          <p:cNvPr id="3" name="Content Placeholder 2">
+      <p:pic>
+        <p:nvPicPr>
+          <p:cNvPr id="7" name="Content Placeholder 6">
             <a:extLst>
               <a:ext uri="{FF2B5EF4-FFF2-40B4-BE49-F238E27FC236}">
-                <a16:creationId xmlns:a16="http://schemas.microsoft.com/office/drawing/2014/main" id="{136CF22E-3FBB-EF53-1CEF-E20C696A863B}"/>
+                <a16:creationId xmlns:a16="http://schemas.microsoft.com/office/drawing/2014/main" id="{C7105A02-F813-7749-154C-C77F2C0DDAFB}"/>
               </a:ext>
             </a:extLst>
           </p:cNvPr>
-          <p:cNvSpPr>
-            <a:spLocks noGrp="1"/>
-          </p:cNvSpPr>
+          <p:cNvPicPr>
+            <a:picLocks noGrp="1" noChangeAspect="1"/>
+          </p:cNvPicPr>
           <p:nvPr>
             <p:ph idx="1"/>
           </p:nvPr>
-        </p:nvSpPr>
-        <p:spPr/>
-        <p:txBody>
-          <a:bodyPr vert="horz" lIns="91440" tIns="45720" rIns="91440" bIns="45720" rtlCol="0" anchor="t">
-            <a:normAutofit/>
-          </a:bodyPr>
-          <a:lstStyle/>
-          <a:p>
-            <a:r>
-              <a:rPr lang="en-GB" dirty="0">
-                <a:solidFill>
-                  <a:schemeClr val="bg1"/>
-                </a:solidFill>
-                <a:latin typeface="ADLaM Display"/>
-                <a:ea typeface="ADLaM Display"/>
-                <a:cs typeface="ADLaM Display"/>
-              </a:rPr>
-              <a:t>After physically repairing the robot with the 3D printer and the new component, the player must then re-establish the wireless network connection between the PC and the robot.</a:t>
-            </a:r>
-          </a:p>
-          <a:p>
-            <a:r>
-              <a:rPr lang="en-GB" dirty="0">
-                <a:solidFill>
-                  <a:schemeClr val="bg1"/>
-                </a:solidFill>
-                <a:latin typeface="ADLaM Display"/>
-                <a:ea typeface="ADLaM Display"/>
-                <a:cs typeface="ADLaM Display"/>
-              </a:rPr>
-              <a:t>Puzzle involves changing IP Address, Subnet Mask and Gateway to make sure the robot and the PC are on the same network, as well as a very basic wiring task.</a:t>
-            </a:r>
-          </a:p>
-          <a:p>
-            <a:r>
-              <a:rPr lang="en-GB">
-                <a:solidFill>
-                  <a:schemeClr val="bg1"/>
-                </a:solidFill>
-                <a:latin typeface="ADLaM Display"/>
-                <a:ea typeface="ADLaM Display"/>
-                <a:cs typeface="ADLaM Display"/>
-              </a:rPr>
-              <a:t>This puzzle highlights the theme of </a:t>
-            </a:r>
-            <a:r>
-              <a:rPr lang="en-GB" b="1" i="1" u="sng">
-                <a:solidFill>
-                  <a:schemeClr val="bg1"/>
-                </a:solidFill>
-                <a:latin typeface="ADLaM Display"/>
-                <a:ea typeface="ADLaM Display"/>
-                <a:cs typeface="ADLaM Display"/>
-              </a:rPr>
-              <a:t>networking</a:t>
-            </a:r>
-            <a:r>
-              <a:rPr lang="en-GB">
-                <a:solidFill>
-                  <a:schemeClr val="bg1"/>
-                </a:solidFill>
-                <a:latin typeface="ADLaM Display"/>
-                <a:ea typeface="ADLaM Display"/>
-                <a:cs typeface="ADLaM Display"/>
-              </a:rPr>
-              <a:t>.</a:t>
-            </a:r>
-            <a:endParaRPr lang="en-GB" dirty="0">
-              <a:solidFill>
-                <a:schemeClr val="bg1"/>
-              </a:solidFill>
-              <a:latin typeface="ADLaM Display"/>
-              <a:ea typeface="ADLaM Display"/>
-              <a:cs typeface="ADLaM Display"/>
-            </a:endParaRPr>
-          </a:p>
-        </p:txBody>
-      </p:sp>
+        </p:nvPicPr>
+        <p:blipFill>
+          <a:blip r:embed="rId2">
+            <a:extLst>
+              <a:ext uri="{28A0092B-C50C-407E-A947-70E740481C1C}">
+                <a14:useLocalDpi xmlns:a14="http://schemas.microsoft.com/office/drawing/2010/main" val="0"/>
+              </a:ext>
+            </a:extLst>
+          </a:blip>
+          <a:stretch>
+            <a:fillRect/>
+          </a:stretch>
+        </p:blipFill>
+        <p:spPr>
+          <a:xfrm>
+            <a:off x="1097432" y="1689869"/>
+            <a:ext cx="9997135" cy="4803006"/>
+          </a:xfrm>
+          <a:prstGeom prst="rect">
+            <a:avLst/>
+          </a:prstGeom>
+        </p:spPr>
+      </p:pic>
     </p:spTree>
     <p:extLst>
       <p:ext uri="{BB962C8B-B14F-4D97-AF65-F5344CB8AC3E}">
-        <p14:creationId xmlns:p14="http://schemas.microsoft.com/office/powerpoint/2010/main" val="1832575804"/>
+        <p14:creationId xmlns:p14="http://schemas.microsoft.com/office/powerpoint/2010/main" val="418780350"/>
       </p:ext>
     </p:extLst>
   </p:cSld>
@@ -3967,7 +3979,7 @@
           <p:cNvPr id="2" name="Title 1">
             <a:extLst>
               <a:ext uri="{FF2B5EF4-FFF2-40B4-BE49-F238E27FC236}">
-                <a16:creationId xmlns:a16="http://schemas.microsoft.com/office/drawing/2014/main" id="{1DF73FFF-FB94-0A8B-926A-93323BB75189}"/>
+                <a16:creationId xmlns:a16="http://schemas.microsoft.com/office/drawing/2014/main" id="{D2A0EA90-589D-C17E-778B-49FE209EC38A}"/>
               </a:ext>
             </a:extLst>
           </p:cNvPr>
@@ -3997,42 +4009,125 @@
           </a:p>
         </p:txBody>
       </p:sp>
-      <p:pic>
-        <p:nvPicPr>
-          <p:cNvPr id="4" name="Content Placeholder 3" descr="A screenshot of a program&#10;&#10;AI-generated content may be incorrect.">
+      <p:sp>
+        <p:nvSpPr>
+          <p:cNvPr id="3" name="Content Placeholder 2">
             <a:extLst>
               <a:ext uri="{FF2B5EF4-FFF2-40B4-BE49-F238E27FC236}">
-                <a16:creationId xmlns:a16="http://schemas.microsoft.com/office/drawing/2014/main" id="{6795FA3F-EDC4-8793-85DD-C9D26843EBE2}"/>
+                <a16:creationId xmlns:a16="http://schemas.microsoft.com/office/drawing/2014/main" id="{E68FEA91-7D53-01F2-E75F-41BD1D3C23F5}"/>
               </a:ext>
             </a:extLst>
           </p:cNvPr>
-          <p:cNvPicPr>
-            <a:picLocks noGrp="1" noChangeAspect="1"/>
-          </p:cNvPicPr>
+          <p:cNvSpPr>
+            <a:spLocks noGrp="1"/>
+          </p:cNvSpPr>
           <p:nvPr>
             <p:ph idx="1"/>
           </p:nvPr>
-        </p:nvPicPr>
-        <p:blipFill>
-          <a:blip r:embed="rId2"/>
-          <a:stretch>
-            <a:fillRect/>
-          </a:stretch>
-        </p:blipFill>
-        <p:spPr>
-          <a:xfrm>
-            <a:off x="1440657" y="1692402"/>
-            <a:ext cx="9310686" cy="4474909"/>
-          </a:xfrm>
-          <a:prstGeom prst="rect">
-            <a:avLst/>
-          </a:prstGeom>
-        </p:spPr>
-      </p:pic>
+        </p:nvSpPr>
+        <p:spPr/>
+        <p:txBody>
+          <a:bodyPr vert="horz" lIns="91440" tIns="45720" rIns="91440" bIns="45720" rtlCol="0" anchor="t">
+            <a:normAutofit/>
+          </a:bodyPr>
+          <a:lstStyle/>
+          <a:p>
+            <a:r>
+              <a:rPr lang="en-GB" dirty="0">
+                <a:solidFill>
+                  <a:schemeClr val="bg1"/>
+                </a:solidFill>
+                <a:latin typeface="ADLaM Display"/>
+                <a:ea typeface="ADLaM Display"/>
+                <a:cs typeface="ADLaM Display"/>
+              </a:rPr>
+              <a:t>The robot's hardware &amp; network connection is repaired, but the code that the robot is curr</a:t>
+            </a:r>
+            <a:r>
+              <a:rPr lang="en-GB">
+                <a:solidFill>
+                  <a:schemeClr val="bg1"/>
+                </a:solidFill>
+                <a:latin typeface="ADLaM Display"/>
+                <a:ea typeface="ADLaM Display"/>
+                <a:cs typeface="ADLaM Display"/>
+              </a:rPr>
+              <a:t>ently running is broken and stuck in a loop.</a:t>
+            </a:r>
+            <a:endParaRPr lang="en-GB" dirty="0">
+              <a:solidFill>
+                <a:schemeClr val="bg1"/>
+              </a:solidFill>
+              <a:latin typeface="ADLaM Display"/>
+              <a:ea typeface="ADLaM Display"/>
+              <a:cs typeface="ADLaM Display"/>
+            </a:endParaRPr>
+          </a:p>
+          <a:p>
+            <a:r>
+              <a:rPr lang="en-GB">
+                <a:solidFill>
+                  <a:schemeClr val="bg1"/>
+                </a:solidFill>
+                <a:latin typeface="ADLaM Display"/>
+                <a:ea typeface="ADLaM Display"/>
+                <a:cs typeface="ADLaM Display"/>
+              </a:rPr>
+              <a:t>The player must use a simple drag-and-drop code editor to guide the robot to follow a path to the door, so that it can open it and thus the player may finally "escape".</a:t>
+            </a:r>
+            <a:endParaRPr lang="en-GB" dirty="0">
+              <a:solidFill>
+                <a:schemeClr val="bg1"/>
+              </a:solidFill>
+              <a:latin typeface="ADLaM Display"/>
+              <a:ea typeface="ADLaM Display"/>
+              <a:cs typeface="ADLaM Display"/>
+            </a:endParaRPr>
+          </a:p>
+          <a:p>
+            <a:r>
+              <a:rPr lang="en-GB" dirty="0">
+                <a:solidFill>
+                  <a:schemeClr val="bg1"/>
+                </a:solidFill>
+                <a:latin typeface="ADLaM Display"/>
+                <a:ea typeface="ADLaM Display"/>
+                <a:cs typeface="ADLaM Display"/>
+              </a:rPr>
+              <a:t>This challenge educates the player in a very basic way about the fundamentals of </a:t>
+            </a:r>
+            <a:r>
+              <a:rPr lang="en-GB" b="1" i="1" u="sng" dirty="0">
+                <a:solidFill>
+                  <a:schemeClr val="bg1"/>
+                </a:solidFill>
+                <a:latin typeface="ADLaM Display"/>
+                <a:ea typeface="ADLaM Display"/>
+                <a:cs typeface="ADLaM Display"/>
+              </a:rPr>
+              <a:t>programming and coding</a:t>
+            </a:r>
+            <a:r>
+              <a:rPr lang="en-GB" dirty="0">
+                <a:solidFill>
+                  <a:schemeClr val="bg1"/>
+                </a:solidFill>
+                <a:latin typeface="ADLaM Display"/>
+                <a:ea typeface="ADLaM Display"/>
+                <a:cs typeface="ADLaM Display"/>
+              </a:rPr>
+              <a:t>.</a:t>
+            </a:r>
+          </a:p>
+          <a:p>
+            <a:endParaRPr lang="en-GB" dirty="0"/>
+          </a:p>
+        </p:txBody>
+      </p:sp>
     </p:spTree>
     <p:extLst>
       <p:ext uri="{BB962C8B-B14F-4D97-AF65-F5344CB8AC3E}">
-        <p14:creationId xmlns:p14="http://schemas.microsoft.com/office/powerpoint/2010/main" val="1124291527"/>
+        <p14:creationId xmlns:p14="http://schemas.microsoft.com/office/powerpoint/2010/main" val="3233528010"/>
       </p:ext>
     </p:extLst>
   </p:cSld>
@@ -4072,7 +4167,7 @@
           <p:cNvPr id="2" name="Title 1">
             <a:extLst>
               <a:ext uri="{FF2B5EF4-FFF2-40B4-BE49-F238E27FC236}">
-                <a16:creationId xmlns:a16="http://schemas.microsoft.com/office/drawing/2014/main" id="{D2A0EA90-589D-C17E-778B-49FE209EC38A}"/>
+                <a16:creationId xmlns:a16="http://schemas.microsoft.com/office/drawing/2014/main" id="{1DF73FFF-FB94-0A8B-926A-93323BB75189}"/>
               </a:ext>
             </a:extLst>
           </p:cNvPr>
@@ -4102,125 +4197,48 @@
           </a:p>
         </p:txBody>
       </p:sp>
-      <p:sp>
-        <p:nvSpPr>
-          <p:cNvPr id="3" name="Content Placeholder 2">
+      <p:pic>
+        <p:nvPicPr>
+          <p:cNvPr id="7" name="Content Placeholder 6">
             <a:extLst>
               <a:ext uri="{FF2B5EF4-FFF2-40B4-BE49-F238E27FC236}">
-                <a16:creationId xmlns:a16="http://schemas.microsoft.com/office/drawing/2014/main" id="{E68FEA91-7D53-01F2-E75F-41BD1D3C23F5}"/>
+                <a16:creationId xmlns:a16="http://schemas.microsoft.com/office/drawing/2014/main" id="{63F5454B-9D22-DE49-1EAD-6935DA64B933}"/>
               </a:ext>
             </a:extLst>
           </p:cNvPr>
-          <p:cNvSpPr>
-            <a:spLocks noGrp="1"/>
-          </p:cNvSpPr>
+          <p:cNvPicPr>
+            <a:picLocks noGrp="1" noChangeAspect="1"/>
+          </p:cNvPicPr>
           <p:nvPr>
             <p:ph idx="1"/>
           </p:nvPr>
-        </p:nvSpPr>
-        <p:spPr/>
-        <p:txBody>
-          <a:bodyPr vert="horz" lIns="91440" tIns="45720" rIns="91440" bIns="45720" rtlCol="0" anchor="t">
-            <a:normAutofit/>
-          </a:bodyPr>
-          <a:lstStyle/>
-          <a:p>
-            <a:r>
-              <a:rPr lang="en-GB" dirty="0">
-                <a:solidFill>
-                  <a:schemeClr val="bg1"/>
-                </a:solidFill>
-                <a:latin typeface="ADLaM Display"/>
-                <a:ea typeface="ADLaM Display"/>
-                <a:cs typeface="ADLaM Display"/>
-              </a:rPr>
-              <a:t>The robot's hardware &amp; network connection is repaired, but the code that the robot is curr</a:t>
-            </a:r>
-            <a:r>
-              <a:rPr lang="en-GB">
-                <a:solidFill>
-                  <a:schemeClr val="bg1"/>
-                </a:solidFill>
-                <a:latin typeface="ADLaM Display"/>
-                <a:ea typeface="ADLaM Display"/>
-                <a:cs typeface="ADLaM Display"/>
-              </a:rPr>
-              <a:t>ently running is broken and stuck in a loop.</a:t>
-            </a:r>
-            <a:endParaRPr lang="en-GB" dirty="0">
-              <a:solidFill>
-                <a:schemeClr val="bg1"/>
-              </a:solidFill>
-              <a:latin typeface="ADLaM Display"/>
-              <a:ea typeface="ADLaM Display"/>
-              <a:cs typeface="ADLaM Display"/>
-            </a:endParaRPr>
-          </a:p>
-          <a:p>
-            <a:r>
-              <a:rPr lang="en-GB">
-                <a:solidFill>
-                  <a:schemeClr val="bg1"/>
-                </a:solidFill>
-                <a:latin typeface="ADLaM Display"/>
-                <a:ea typeface="ADLaM Display"/>
-                <a:cs typeface="ADLaM Display"/>
-              </a:rPr>
-              <a:t>The player must use a simple drag-and-drop code editor to guide the robot to follow a path to the door, so that it can open it and thus the player may finally "escape".</a:t>
-            </a:r>
-            <a:endParaRPr lang="en-GB" dirty="0">
-              <a:solidFill>
-                <a:schemeClr val="bg1"/>
-              </a:solidFill>
-              <a:latin typeface="ADLaM Display"/>
-              <a:ea typeface="ADLaM Display"/>
-              <a:cs typeface="ADLaM Display"/>
-            </a:endParaRPr>
-          </a:p>
-          <a:p>
-            <a:r>
-              <a:rPr lang="en-GB" dirty="0">
-                <a:solidFill>
-                  <a:schemeClr val="bg1"/>
-                </a:solidFill>
-                <a:latin typeface="ADLaM Display"/>
-                <a:ea typeface="ADLaM Display"/>
-                <a:cs typeface="ADLaM Display"/>
-              </a:rPr>
-              <a:t>This challenge educates the player in a very basic way about the fundamentals of </a:t>
-            </a:r>
-            <a:r>
-              <a:rPr lang="en-GB" b="1" i="1" u="sng" dirty="0">
-                <a:solidFill>
-                  <a:schemeClr val="bg1"/>
-                </a:solidFill>
-                <a:latin typeface="ADLaM Display"/>
-                <a:ea typeface="ADLaM Display"/>
-                <a:cs typeface="ADLaM Display"/>
-              </a:rPr>
-              <a:t>programming and coding</a:t>
-            </a:r>
-            <a:r>
-              <a:rPr lang="en-GB" dirty="0">
-                <a:solidFill>
-                  <a:schemeClr val="bg1"/>
-                </a:solidFill>
-                <a:latin typeface="ADLaM Display"/>
-                <a:ea typeface="ADLaM Display"/>
-                <a:cs typeface="ADLaM Display"/>
-              </a:rPr>
-              <a:t>.</a:t>
-            </a:r>
-          </a:p>
-          <a:p>
-            <a:endParaRPr lang="en-GB" dirty="0"/>
-          </a:p>
-        </p:txBody>
-      </p:sp>
+        </p:nvPicPr>
+        <p:blipFill>
+          <a:blip r:embed="rId2">
+            <a:extLst>
+              <a:ext uri="{28A0092B-C50C-407E-A947-70E740481C1C}">
+                <a14:useLocalDpi xmlns:a14="http://schemas.microsoft.com/office/drawing/2010/main" val="0"/>
+              </a:ext>
+            </a:extLst>
+          </a:blip>
+          <a:stretch>
+            <a:fillRect/>
+          </a:stretch>
+        </p:blipFill>
+        <p:spPr>
+          <a:xfrm>
+            <a:off x="1154667" y="1690688"/>
+            <a:ext cx="9882665" cy="4766145"/>
+          </a:xfrm>
+          <a:prstGeom prst="rect">
+            <a:avLst/>
+          </a:prstGeom>
+        </p:spPr>
+      </p:pic>
     </p:spTree>
     <p:extLst>
       <p:ext uri="{BB962C8B-B14F-4D97-AF65-F5344CB8AC3E}">
-        <p14:creationId xmlns:p14="http://schemas.microsoft.com/office/powerpoint/2010/main" val="3233528010"/>
+        <p14:creationId xmlns:p14="http://schemas.microsoft.com/office/powerpoint/2010/main" val="1124291527"/>
       </p:ext>
     </p:extLst>
   </p:cSld>

</xml_diff>